<commit_message>
added onedrive link for video
</commit_message>
<xml_diff>
--- a/Project1-CEP.pptx
+++ b/Project1-CEP.pptx
@@ -119,6 +119,11 @@
       </a:defRPr>
     </a:lvl9pPr>
   </p:defaultTextStyle>
+  <p:extLst>
+    <p:ext uri="{EFAFB233-063F-42B5-8137-9DF3F51BA10A}">
+      <p15:sldGuideLst xmlns:p15="http://schemas.microsoft.com/office/powerpoint/2012/main"/>
+    </p:ext>
+  </p:extLst>
 </p:presentation>
 </file>
 
@@ -1039,7 +1044,7 @@
           <a:p>
             <a:fld id="{40899192-E373-4909-AFEA-98ED94179BF6}" type="datetimeFigureOut">
               <a:rPr lang="en-CA" smtClean="0"/>
-              <a:t>2026-10-17</a:t>
+              <a:t>2026-10-23</a:t>
             </a:fld>
             <a:endParaRPr lang="en-CA"/>
           </a:p>
@@ -1251,7 +1256,7 @@
           <a:p>
             <a:fld id="{40899192-E373-4909-AFEA-98ED94179BF6}" type="datetimeFigureOut">
               <a:rPr lang="en-CA" smtClean="0"/>
-              <a:t>2026-10-17</a:t>
+              <a:t>2026-10-23</a:t>
             </a:fld>
             <a:endParaRPr lang="en-CA"/>
           </a:p>
@@ -1473,7 +1478,7 @@
           <a:p>
             <a:fld id="{40899192-E373-4909-AFEA-98ED94179BF6}" type="datetimeFigureOut">
               <a:rPr lang="en-CA" smtClean="0"/>
-              <a:t>2026-10-17</a:t>
+              <a:t>2026-10-23</a:t>
             </a:fld>
             <a:endParaRPr lang="en-CA"/>
           </a:p>
@@ -1685,7 +1690,7 @@
           <a:p>
             <a:fld id="{40899192-E373-4909-AFEA-98ED94179BF6}" type="datetimeFigureOut">
               <a:rPr lang="en-CA" smtClean="0"/>
-              <a:t>2026-10-17</a:t>
+              <a:t>2026-10-23</a:t>
             </a:fld>
             <a:endParaRPr lang="en-CA"/>
           </a:p>
@@ -1973,7 +1978,7 @@
           <a:p>
             <a:fld id="{40899192-E373-4909-AFEA-98ED94179BF6}" type="datetimeFigureOut">
               <a:rPr lang="en-CA" smtClean="0"/>
-              <a:t>2026-10-17</a:t>
+              <a:t>2026-10-23</a:t>
             </a:fld>
             <a:endParaRPr lang="en-CA"/>
           </a:p>
@@ -2253,7 +2258,7 @@
           <a:p>
             <a:fld id="{40899192-E373-4909-AFEA-98ED94179BF6}" type="datetimeFigureOut">
               <a:rPr lang="en-CA" smtClean="0"/>
-              <a:t>2026-10-17</a:t>
+              <a:t>2026-10-23</a:t>
             </a:fld>
             <a:endParaRPr lang="en-CA"/>
           </a:p>
@@ -2680,7 +2685,7 @@
           <a:p>
             <a:fld id="{40899192-E373-4909-AFEA-98ED94179BF6}" type="datetimeFigureOut">
               <a:rPr lang="en-CA" smtClean="0"/>
-              <a:t>2026-10-17</a:t>
+              <a:t>2026-10-23</a:t>
             </a:fld>
             <a:endParaRPr lang="en-CA"/>
           </a:p>
@@ -2834,7 +2839,7 @@
           <a:p>
             <a:fld id="{40899192-E373-4909-AFEA-98ED94179BF6}" type="datetimeFigureOut">
               <a:rPr lang="en-CA" smtClean="0"/>
-              <a:t>2026-10-17</a:t>
+              <a:t>2026-10-23</a:t>
             </a:fld>
             <a:endParaRPr lang="en-CA"/>
           </a:p>
@@ -2959,7 +2964,7 @@
           <a:p>
             <a:fld id="{40899192-E373-4909-AFEA-98ED94179BF6}" type="datetimeFigureOut">
               <a:rPr lang="en-CA" smtClean="0"/>
-              <a:t>2026-10-17</a:t>
+              <a:t>2026-10-23</a:t>
             </a:fld>
             <a:endParaRPr lang="en-CA"/>
           </a:p>
@@ -3284,7 +3289,7 @@
           <a:p>
             <a:fld id="{40899192-E373-4909-AFEA-98ED94179BF6}" type="datetimeFigureOut">
               <a:rPr lang="en-CA" smtClean="0"/>
-              <a:t>2026-10-17</a:t>
+              <a:t>2026-10-23</a:t>
             </a:fld>
             <a:endParaRPr lang="en-CA"/>
           </a:p>
@@ -3585,7 +3590,7 @@
           <a:p>
             <a:fld id="{40899192-E373-4909-AFEA-98ED94179BF6}" type="datetimeFigureOut">
               <a:rPr lang="en-CA" smtClean="0"/>
-              <a:t>2026-10-17</a:t>
+              <a:t>2026-10-23</a:t>
             </a:fld>
             <a:endParaRPr lang="en-CA"/>
           </a:p>
@@ -3840,7 +3845,7 @@
           <a:p>
             <a:fld id="{40899192-E373-4909-AFEA-98ED94179BF6}" type="datetimeFigureOut">
               <a:rPr lang="en-CA" smtClean="0"/>
-              <a:t>2026-10-17</a:t>
+              <a:t>2026-10-23</a:t>
             </a:fld>
             <a:endParaRPr lang="en-CA"/>
           </a:p>
@@ -4405,23 +4410,46 @@
           <a:lstStyle/>
           <a:p>
             <a:r>
-              <a:rPr lang="en-US" sz="1400">
+              <a:rPr lang="en-US" sz="1400" dirty="0">
                 <a:solidFill>
                   <a:schemeClr val="bg1"/>
                 </a:solidFill>
               </a:rPr>
-              <a:t>Team member – Kyaw </a:t>
-            </a:r>
-            <a:r>
-              <a:rPr lang="en-US" sz="1400" err="1">
+              <a:t>Team member – Kyaw Bhone </a:t>
+            </a:r>
+            <a:r>
+              <a:rPr lang="en-US" sz="1400" dirty="0" err="1">
                 <a:solidFill>
                   <a:schemeClr val="bg1"/>
                 </a:solidFill>
               </a:rPr>
-              <a:t>Bhone</a:t>
-            </a:r>
-            <a:r>
-              <a:rPr lang="en-US" sz="1400">
+              <a:t>khant</a:t>
+            </a:r>
+            <a:endParaRPr lang="en-US" sz="1400" dirty="0">
+              <a:solidFill>
+                <a:schemeClr val="bg1"/>
+              </a:solidFill>
+            </a:endParaRPr>
+          </a:p>
+          <a:p>
+            <a:r>
+              <a:rPr lang="en-CA" sz="1400" dirty="0">
+                <a:solidFill>
+                  <a:schemeClr val="bg1"/>
+                </a:solidFill>
+              </a:rPr>
+              <a:t>	           </a:t>
+            </a:r>
+            <a:r>
+              <a:rPr lang="en-CA" sz="1400" dirty="0" err="1">
+                <a:solidFill>
+                  <a:schemeClr val="bg1"/>
+                </a:solidFill>
+              </a:rPr>
+              <a:t>Sparshdeep</a:t>
+            </a:r>
+            <a:r>
+              <a:rPr lang="en-CA" sz="1400" dirty="0">
                 <a:solidFill>
                   <a:schemeClr val="bg1"/>
                 </a:solidFill>
@@ -4429,53 +4457,14 @@
               <a:t> </a:t>
             </a:r>
             <a:r>
-              <a:rPr lang="en-US" sz="1400" err="1">
-                <a:solidFill>
-                  <a:schemeClr val="bg1"/>
-                </a:solidFill>
-              </a:rPr>
-              <a:t>khant</a:t>
-            </a:r>
-            <a:endParaRPr lang="en-US" sz="1400">
-              <a:solidFill>
-                <a:schemeClr val="bg1"/>
-              </a:solidFill>
-            </a:endParaRPr>
-          </a:p>
-          <a:p>
-            <a:r>
-              <a:rPr lang="en-CA" sz="1400">
-                <a:solidFill>
-                  <a:schemeClr val="bg1"/>
-                </a:solidFill>
-              </a:rPr>
-              <a:t>	           </a:t>
-            </a:r>
-            <a:r>
-              <a:rPr lang="en-CA" sz="1400" err="1">
-                <a:solidFill>
-                  <a:schemeClr val="bg1"/>
-                </a:solidFill>
-              </a:rPr>
-              <a:t>Sparshdeep</a:t>
-            </a:r>
-            <a:r>
-              <a:rPr lang="en-CA" sz="1400">
-                <a:solidFill>
-                  <a:schemeClr val="bg1"/>
-                </a:solidFill>
-              </a:rPr>
-              <a:t> </a:t>
-            </a:r>
-            <a:r>
-              <a:rPr lang="en-CA" sz="1400" err="1">
+              <a:rPr lang="en-CA" sz="1400" dirty="0" err="1">
                 <a:solidFill>
                   <a:schemeClr val="bg1"/>
                 </a:solidFill>
               </a:rPr>
               <a:t>kaur</a:t>
             </a:r>
-            <a:endParaRPr lang="en-CA" sz="1400">
+            <a:endParaRPr lang="en-CA" sz="1400" dirty="0">
               <a:solidFill>
                 <a:schemeClr val="bg1"/>
               </a:solidFill>
@@ -4483,7 +4472,7 @@
           </a:p>
           <a:p>
             <a:r>
-              <a:rPr lang="en-CA" sz="1400">
+              <a:rPr lang="en-CA" sz="1400" dirty="0">
                 <a:solidFill>
                   <a:schemeClr val="bg1"/>
                 </a:solidFill>
@@ -4567,105 +4556,14 @@
                             </p:stCondLst>
                             <p:childTnLst>
                               <p:par>
-                                <p:cTn id="5" presetID="2" presetClass="exit" presetSubtype="4" fill="hold" grpId="0" nodeType="clickEffect">
-                                  <p:stCondLst>
-                                    <p:cond delay="0"/>
-                                  </p:stCondLst>
-                                  <p:childTnLst>
-                                    <p:anim calcmode="lin" valueType="num">
-                                      <p:cBhvr additive="base">
-                                        <p:cTn id="6" dur="500"/>
-                                        <p:tgtEl>
-                                          <p:spTgt spid="7"/>
-                                        </p:tgtEl>
-                                        <p:attrNameLst>
-                                          <p:attrName>ppt_x</p:attrName>
-                                        </p:attrNameLst>
-                                      </p:cBhvr>
-                                      <p:tavLst>
-                                        <p:tav tm="0">
-                                          <p:val>
-                                            <p:strVal val="ppt_x"/>
-                                          </p:val>
-                                        </p:tav>
-                                        <p:tav tm="100000">
-                                          <p:val>
-                                            <p:strVal val="ppt_x"/>
-                                          </p:val>
-                                        </p:tav>
-                                      </p:tavLst>
-                                    </p:anim>
-                                    <p:anim calcmode="lin" valueType="num">
-                                      <p:cBhvr additive="base">
-                                        <p:cTn id="7" dur="500"/>
-                                        <p:tgtEl>
-                                          <p:spTgt spid="7"/>
-                                        </p:tgtEl>
-                                        <p:attrNameLst>
-                                          <p:attrName>ppt_y</p:attrName>
-                                        </p:attrNameLst>
-                                      </p:cBhvr>
-                                      <p:tavLst>
-                                        <p:tav tm="0">
-                                          <p:val>
-                                            <p:strVal val="ppt_y"/>
-                                          </p:val>
-                                        </p:tav>
-                                        <p:tav tm="100000">
-                                          <p:val>
-                                            <p:strVal val="1+ppt_h/2"/>
-                                          </p:val>
-                                        </p:tav>
-                                      </p:tavLst>
-                                    </p:anim>
-                                    <p:set>
-                                      <p:cBhvr>
-                                        <p:cTn id="8" dur="1" fill="hold">
-                                          <p:stCondLst>
-                                            <p:cond delay="499"/>
-                                          </p:stCondLst>
-                                        </p:cTn>
-                                        <p:tgtEl>
-                                          <p:spTgt spid="7"/>
-                                        </p:tgtEl>
-                                        <p:attrNameLst>
-                                          <p:attrName>style.visibility</p:attrName>
-                                        </p:attrNameLst>
-                                      </p:cBhvr>
-                                      <p:to>
-                                        <p:strVal val="hidden"/>
-                                      </p:to>
-                                    </p:set>
-                                  </p:childTnLst>
-                                </p:cTn>
-                              </p:par>
-                            </p:childTnLst>
-                          </p:cTn>
-                        </p:par>
-                      </p:childTnLst>
-                    </p:cTn>
-                  </p:par>
-                  <p:par>
-                    <p:cTn id="9" fill="hold">
-                      <p:stCondLst>
-                        <p:cond delay="indefinite"/>
-                      </p:stCondLst>
-                      <p:childTnLst>
-                        <p:par>
-                          <p:cTn id="10" fill="hold">
-                            <p:stCondLst>
-                              <p:cond delay="0"/>
-                            </p:stCondLst>
-                            <p:childTnLst>
-                              <p:par>
-                                <p:cTn id="11" presetID="26" presetClass="entr" presetSubtype="0" fill="hold" grpId="0" nodeType="clickEffect">
+                                <p:cTn id="5" presetID="26" presetClass="entr" presetSubtype="0" fill="hold" grpId="0" nodeType="clickEffect">
                                   <p:stCondLst>
                                     <p:cond delay="0"/>
                                   </p:stCondLst>
                                   <p:childTnLst>
                                     <p:set>
                                       <p:cBhvr>
-                                        <p:cTn id="12" dur="1" fill="hold">
+                                        <p:cTn id="6" dur="1" fill="hold">
                                           <p:stCondLst>
                                             <p:cond delay="0"/>
                                           </p:stCondLst>
@@ -4683,7 +4581,7 @@
                                     </p:set>
                                     <p:animEffect transition="in" filter="wipe(down)">
                                       <p:cBhvr>
-                                        <p:cTn id="13" dur="580">
+                                        <p:cTn id="7" dur="580">
                                           <p:stCondLst>
                                             <p:cond delay="0"/>
                                           </p:stCondLst>
@@ -4695,7 +4593,7 @@
                                     </p:animEffect>
                                     <p:anim calcmode="lin" valueType="num">
                                       <p:cBhvr>
-                                        <p:cTn id="14" dur="1822" tmFilter="0,0; 0.14,0.36; 0.43,0.73; 0.71,0.91; 1.0,1.0">
+                                        <p:cTn id="8" dur="1822" tmFilter="0,0; 0.14,0.36; 0.43,0.73; 0.71,0.91; 1.0,1.0">
                                           <p:stCondLst>
                                             <p:cond delay="0"/>
                                           </p:stCondLst>
@@ -4722,7 +4620,7 @@
                                     </p:anim>
                                     <p:anim calcmode="lin" valueType="num">
                                       <p:cBhvr>
-                                        <p:cTn id="15" dur="664" tmFilter="0.0,0.0; 0.25,0.07; 0.50,0.2; 0.75,0.467; 1.0,1.0">
+                                        <p:cTn id="9" dur="664" tmFilter="0.0,0.0; 0.25,0.07; 0.50,0.2; 0.75,0.467; 1.0,1.0">
                                           <p:stCondLst>
                                             <p:cond delay="0"/>
                                           </p:stCondLst>
@@ -4749,7 +4647,7 @@
                                     </p:anim>
                                     <p:anim calcmode="lin" valueType="num">
                                       <p:cBhvr>
-                                        <p:cTn id="16" dur="664" tmFilter="0, 0; 0.125,0.2665; 0.25,0.4; 0.375,0.465; 0.5,0.5;  0.625,0.535; 0.75,0.6; 0.875,0.7335; 1,1">
+                                        <p:cTn id="10" dur="664" tmFilter="0, 0; 0.125,0.2665; 0.25,0.4; 0.375,0.465; 0.5,0.5;  0.625,0.535; 0.75,0.6; 0.875,0.7335; 1,1">
                                           <p:stCondLst>
                                             <p:cond delay="664"/>
                                           </p:stCondLst>
@@ -4776,7 +4674,7 @@
                                     </p:anim>
                                     <p:anim calcmode="lin" valueType="num">
                                       <p:cBhvr>
-                                        <p:cTn id="17" dur="332" tmFilter="0, 0; 0.125,0.2665; 0.25,0.4; 0.375,0.465; 0.5,0.5;  0.625,0.535; 0.75,0.6; 0.875,0.7335; 1,1">
+                                        <p:cTn id="11" dur="332" tmFilter="0, 0; 0.125,0.2665; 0.25,0.4; 0.375,0.465; 0.5,0.5;  0.625,0.535; 0.75,0.6; 0.875,0.7335; 1,1">
                                           <p:stCondLst>
                                             <p:cond delay="1324"/>
                                           </p:stCondLst>
@@ -4803,7 +4701,7 @@
                                     </p:anim>
                                     <p:anim calcmode="lin" valueType="num">
                                       <p:cBhvr>
-                                        <p:cTn id="18" dur="164" tmFilter="0, 0; 0.125,0.2665; 0.25,0.4; 0.375,0.465; 0.5,0.5;  0.625,0.535; 0.75,0.6; 0.875,0.7335; 1,1">
+                                        <p:cTn id="12" dur="164" tmFilter="0, 0; 0.125,0.2665; 0.25,0.4; 0.375,0.465; 0.5,0.5;  0.625,0.535; 0.75,0.6; 0.875,0.7335; 1,1">
                                           <p:stCondLst>
                                             <p:cond delay="1656"/>
                                           </p:stCondLst>
@@ -4830,7 +4728,7 @@
                                     </p:anim>
                                     <p:animScale>
                                       <p:cBhvr>
-                                        <p:cTn id="19" dur="26">
+                                        <p:cTn id="13" dur="26">
                                           <p:stCondLst>
                                             <p:cond delay="650"/>
                                           </p:stCondLst>
@@ -4843,7 +4741,7 @@
                                     </p:animScale>
                                     <p:animScale>
                                       <p:cBhvr>
-                                        <p:cTn id="20" dur="166" decel="50000">
+                                        <p:cTn id="14" dur="166" decel="50000">
                                           <p:stCondLst>
                                             <p:cond delay="676"/>
                                           </p:stCondLst>
@@ -4856,7 +4754,7 @@
                                     </p:animScale>
                                     <p:animScale>
                                       <p:cBhvr>
-                                        <p:cTn id="21" dur="26">
+                                        <p:cTn id="15" dur="26">
                                           <p:stCondLst>
                                             <p:cond delay="1312"/>
                                           </p:stCondLst>
@@ -4869,7 +4767,7 @@
                                     </p:animScale>
                                     <p:animScale>
                                       <p:cBhvr>
-                                        <p:cTn id="22" dur="166" decel="50000">
+                                        <p:cTn id="16" dur="166" decel="50000">
                                           <p:stCondLst>
                                             <p:cond delay="1338"/>
                                           </p:stCondLst>
@@ -4882,7 +4780,7 @@
                                     </p:animScale>
                                     <p:animScale>
                                       <p:cBhvr>
-                                        <p:cTn id="23" dur="26">
+                                        <p:cTn id="17" dur="26">
                                           <p:stCondLst>
                                             <p:cond delay="1642"/>
                                           </p:stCondLst>
@@ -4895,7 +4793,7 @@
                                     </p:animScale>
                                     <p:animScale>
                                       <p:cBhvr>
-                                        <p:cTn id="24" dur="166" decel="50000">
+                                        <p:cTn id="18" dur="166" decel="50000">
                                           <p:stCondLst>
                                             <p:cond delay="1668"/>
                                           </p:stCondLst>
@@ -4908,7 +4806,7 @@
                                     </p:animScale>
                                     <p:animScale>
                                       <p:cBhvr>
-                                        <p:cTn id="25" dur="26">
+                                        <p:cTn id="19" dur="26">
                                           <p:stCondLst>
                                             <p:cond delay="1808"/>
                                           </p:stCondLst>
@@ -4921,7 +4819,7 @@
                                     </p:animScale>
                                     <p:animScale>
                                       <p:cBhvr>
-                                        <p:cTn id="26" dur="166" decel="50000">
+                                        <p:cTn id="20" dur="166" decel="50000">
                                           <p:stCondLst>
                                             <p:cond delay="1834"/>
                                           </p:stCondLst>
@@ -4932,6 +4830,59 @@
                                       </p:cBhvr>
                                       <p:to x="100000" y="100000"/>
                                     </p:animScale>
+                                  </p:childTnLst>
+                                </p:cTn>
+                              </p:par>
+                            </p:childTnLst>
+                          </p:cTn>
+                        </p:par>
+                      </p:childTnLst>
+                    </p:cTn>
+                  </p:par>
+                  <p:par>
+                    <p:cTn id="21" fill="hold">
+                      <p:stCondLst>
+                        <p:cond delay="indefinite"/>
+                      </p:stCondLst>
+                      <p:childTnLst>
+                        <p:par>
+                          <p:cTn id="22" fill="hold">
+                            <p:stCondLst>
+                              <p:cond delay="0"/>
+                            </p:stCondLst>
+                            <p:childTnLst>
+                              <p:par>
+                                <p:cTn id="23" presetID="16" presetClass="entr" presetSubtype="21" fill="hold" grpId="0" nodeType="clickEffect">
+                                  <p:stCondLst>
+                                    <p:cond delay="0"/>
+                                  </p:stCondLst>
+                                  <p:childTnLst>
+                                    <p:set>
+                                      <p:cBhvr>
+                                        <p:cTn id="24" dur="1" fill="hold">
+                                          <p:stCondLst>
+                                            <p:cond delay="0"/>
+                                          </p:stCondLst>
+                                        </p:cTn>
+                                        <p:tgtEl>
+                                          <p:spTgt spid="7"/>
+                                        </p:tgtEl>
+                                        <p:attrNameLst>
+                                          <p:attrName>style.visibility</p:attrName>
+                                        </p:attrNameLst>
+                                      </p:cBhvr>
+                                      <p:to>
+                                        <p:strVal val="visible"/>
+                                      </p:to>
+                                    </p:set>
+                                    <p:animEffect transition="in" filter="barn(inVertical)">
+                                      <p:cBhvr>
+                                        <p:cTn id="25" dur="500"/>
+                                        <p:tgtEl>
+                                          <p:spTgt spid="7"/>
+                                        </p:tgtEl>
+                                      </p:cBhvr>
+                                    </p:animEffect>
                                   </p:childTnLst>
                                 </p:cTn>
                               </p:par>
@@ -6677,7 +6628,7 @@
         <p:spPr>
           <a:xfrm>
             <a:off x="1708802" y="0"/>
-            <a:ext cx="9304655" cy="2308324"/>
+            <a:ext cx="9304655" cy="1077218"/>
           </a:xfrm>
           <a:prstGeom prst="rect">
             <a:avLst/>
@@ -6695,20 +6646,20 @@
           <a:p>
             <a:pPr algn="ctr"/>
             <a:r>
-              <a:rPr lang="en-US" sz="1600" b="1" i="1" u="sng">
+              <a:rPr lang="en-US" sz="1600" b="1" i="1" u="sng" dirty="0">
                 <a:ea typeface="+mn-lt"/>
                 <a:cs typeface="+mn-lt"/>
               </a:rPr>
               <a:t>Common Multi-Agent Workflows</a:t>
             </a:r>
-            <a:endParaRPr lang="en-US" sz="1600" b="1" i="1" u="sng"/>
+            <a:endParaRPr lang="en-US" sz="1600" b="1" i="1" u="sng" dirty="0"/>
           </a:p>
           <a:p>
             <a:pPr marL="228600" indent="-228600">
               <a:buAutoNum type="arabicPeriod"/>
             </a:pPr>
             <a:r>
-              <a:rPr lang="en-US" sz="1600">
+              <a:rPr lang="en-US" sz="1600" dirty="0">
                 <a:ea typeface="+mn-lt"/>
                 <a:cs typeface="+mn-lt"/>
               </a:rPr>
@@ -6720,7 +6671,7 @@
               <a:buAutoNum type="arabicPeriod"/>
             </a:pPr>
             <a:r>
-              <a:rPr lang="en-US" sz="1600">
+              <a:rPr lang="en-US" sz="1600" dirty="0">
                 <a:ea typeface="+mn-lt"/>
                 <a:cs typeface="+mn-lt"/>
               </a:rPr>
@@ -6732,30 +6683,9 @@
               <a:buAutoNum type="arabicPeriod"/>
             </a:pPr>
             <a:r>
-              <a:rPr lang="en-US" sz="1600"/>
+              <a:rPr lang="en-US" sz="1600" dirty="0"/>
               <a:t>Shared Workspaces: Agents collaborate through shared repositories and project tools.</a:t>
             </a:r>
-          </a:p>
-          <a:p>
-            <a:pPr marL="228600" indent="-228600">
-              <a:buAutoNum type="arabicPeriod"/>
-            </a:pPr>
-            <a:r>
-              <a:rPr lang="en-US" sz="1600"/>
-              <a:t>What Makes It Work? Clear plans, separate roles, good communication, and human supervision.</a:t>
-            </a:r>
-          </a:p>
-          <a:p>
-            <a:endParaRPr lang="en-US" sz="1600"/>
-          </a:p>
-          <a:p>
-            <a:endParaRPr lang="en-US" sz="1600"/>
-          </a:p>
-          <a:p>
-            <a:endParaRPr lang="en-US" sz="1600"/>
-          </a:p>
-          <a:p>
-            <a:endParaRPr lang="en-US" sz="1600"/>
           </a:p>
         </p:txBody>
       </p:sp>
@@ -6901,7 +6831,7 @@
         <p:spPr>
           <a:xfrm>
             <a:off x="84083" y="1836906"/>
-            <a:ext cx="2627586" cy="4278094"/>
+            <a:ext cx="2627586" cy="2800767"/>
           </a:xfrm>
           <a:prstGeom prst="rect">
             <a:avLst/>
@@ -6919,13 +6849,13 @@
           <a:p>
             <a:pPr algn="ctr"/>
             <a:r>
-              <a:rPr lang="en-US" sz="1600">
+              <a:rPr lang="en-US" sz="1600" dirty="0">
                 <a:ea typeface="+mn-lt"/>
                 <a:cs typeface="+mn-lt"/>
               </a:rPr>
               <a:t>Challenges and Limitations</a:t>
             </a:r>
-            <a:endParaRPr lang="en-US" sz="1600"/>
+            <a:endParaRPr lang="en-US" sz="1600" dirty="0"/>
           </a:p>
           <a:p>
             <a:pPr marL="285750" indent="-285750">
@@ -6933,13 +6863,13 @@
               <a:buChar char="•"/>
             </a:pPr>
             <a:r>
-              <a:rPr lang="en-US" sz="1600">
+              <a:rPr lang="en-US" sz="1600" dirty="0">
                 <a:ea typeface="+mn-lt"/>
                 <a:cs typeface="+mn-lt"/>
               </a:rPr>
               <a:t>High costs: Running multiple AI agents can require significant computing resources and money.</a:t>
             </a:r>
-            <a:endParaRPr lang="en-US" sz="1600"/>
+            <a:endParaRPr lang="en-US" sz="1600" dirty="0"/>
           </a:p>
           <a:p>
             <a:pPr marL="285750" indent="-285750">
@@ -6947,31 +6877,13 @@
               <a:buChar char="•"/>
             </a:pPr>
             <a:r>
-              <a:rPr lang="en-US" sz="1600">
+              <a:rPr lang="en-US" sz="1600" dirty="0">
                 <a:ea typeface="+mn-lt"/>
                 <a:cs typeface="+mn-lt"/>
               </a:rPr>
               <a:t>Security risks: More agents with access to code or infrastructure can create more security vulnerabilities.</a:t>
             </a:r>
-            <a:endParaRPr lang="en-US" sz="1600"/>
-          </a:p>
-          <a:p>
-            <a:pPr marL="285750" indent="-285750">
-              <a:buFont typeface="Arial"/>
-              <a:buChar char="•"/>
-            </a:pPr>
-            <a:r>
-              <a:rPr lang="en-US" sz="1600">
-                <a:ea typeface="+mn-lt"/>
-                <a:cs typeface="+mn-lt"/>
-              </a:rPr>
-              <a:t>Access control: Each agent should have limited permissions, and its actions should be tracked.</a:t>
-            </a:r>
-            <a:endParaRPr lang="en-US" sz="1600"/>
-          </a:p>
-          <a:p>
-            <a:pPr algn="l"/>
-            <a:endParaRPr lang="en-US" sz="1600"/>
+            <a:endParaRPr lang="en-US" sz="1600" dirty="0"/>
           </a:p>
         </p:txBody>
       </p:sp>
@@ -10992,23 +10904,6 @@
 </file>
 
 <file path=customXml/item1.xml><?xml version="1.0" encoding="utf-8"?>
-<?mso-contentType ?>
-<FormTemplates xmlns="http://schemas.microsoft.com/sharepoint/v3/contenttype/forms">
-  <Display>DocumentLibraryForm</Display>
-  <Edit>DocumentLibraryForm</Edit>
-  <New>DocumentLibraryForm</New>
-</FormTemplates>
-</file>
-
-<file path=customXml/item2.xml><?xml version="1.0" encoding="utf-8"?>
-<p:properties xmlns:p="http://schemas.microsoft.com/office/2006/metadata/properties" xmlns:xsi="http://www.w3.org/2001/XMLSchema-instance" xmlns:pc="http://schemas.microsoft.com/office/infopath/2007/PartnerControls">
-  <documentManagement>
-    <_activity xmlns="539bf27b-6ba9-4563-9663-8e6293fc5b3b" xsi:nil="true"/>
-  </documentManagement>
-</p:properties>
-</file>
-
-<file path=customXml/item3.xml><?xml version="1.0" encoding="utf-8"?>
 <ct:contentTypeSchema xmlns:ct="http://schemas.microsoft.com/office/2006/metadata/contentType" xmlns:ma="http://schemas.microsoft.com/office/2006/metadata/properties/metaAttributes" ct:_="" ma:_="" ma:contentTypeName="Document" ma:contentTypeID="0x01010092FD68050CE9C44E82E36CC62424E620" ma:contentTypeVersion="5" ma:contentTypeDescription="Create a new document." ma:contentTypeScope="" ma:versionID="8421d284d7f2948e0cc451668b4ca7c0">
   <xsd:schema xmlns:xsd="http://www.w3.org/2001/XMLSchema" xmlns:xs="http://www.w3.org/2001/XMLSchema" xmlns:p="http://schemas.microsoft.com/office/2006/metadata/properties" xmlns:ns3="539bf27b-6ba9-4563-9663-8e6293fc5b3b" targetNamespace="http://schemas.microsoft.com/office/2006/metadata/properties" ma:root="true" ma:fieldsID="c2ca6bfd6f9dc7e4f37f19ae994e1e63" ns3:_="">
     <xsd:import namespace="539bf27b-6ba9-4563-9663-8e6293fc5b3b"/>
@@ -11158,31 +11053,24 @@
 </ct:contentTypeSchema>
 </file>
 
-<file path=customXml/itemProps1.xml><?xml version="1.0" encoding="utf-8"?>
-<ds:datastoreItem xmlns:ds="http://schemas.openxmlformats.org/officeDocument/2006/customXml" ds:itemID="{349F7CF4-910C-43BC-9DCB-33F198C0109A}">
-  <ds:schemaRefs>
-    <ds:schemaRef ds:uri="http://schemas.microsoft.com/sharepoint/v3/contenttype/forms"/>
-  </ds:schemaRefs>
-</ds:datastoreItem>
+<file path=customXml/item2.xml><?xml version="1.0" encoding="utf-8"?>
+<?mso-contentType ?>
+<FormTemplates xmlns="http://schemas.microsoft.com/sharepoint/v3/contenttype/forms">
+  <Display>DocumentLibraryForm</Display>
+  <Edit>DocumentLibraryForm</Edit>
+  <New>DocumentLibraryForm</New>
+</FormTemplates>
 </file>
 
-<file path=customXml/itemProps2.xml><?xml version="1.0" encoding="utf-8"?>
-<ds:datastoreItem xmlns:ds="http://schemas.openxmlformats.org/officeDocument/2006/customXml" ds:itemID="{83B8D32C-C616-450A-A725-A432762E03AB}">
-  <ds:schemaRefs>
-    <ds:schemaRef ds:uri="539bf27b-6ba9-4563-9663-8e6293fc5b3b"/>
-    <ds:schemaRef ds:uri="http://purl.org/dc/dcmitype/"/>
-    <ds:schemaRef ds:uri="http://purl.org/dc/elements/1.1/"/>
-    <ds:schemaRef ds:uri="http://purl.org/dc/terms/"/>
-    <ds:schemaRef ds:uri="http://schemas.microsoft.com/office/2006/documentManagement/types"/>
-    <ds:schemaRef ds:uri="http://schemas.microsoft.com/office/2006/metadata/properties"/>
-    <ds:schemaRef ds:uri="http://schemas.microsoft.com/office/infopath/2007/PartnerControls"/>
-    <ds:schemaRef ds:uri="http://schemas.openxmlformats.org/package/2006/metadata/core-properties"/>
-    <ds:schemaRef ds:uri="http://www.w3.org/XML/1998/namespace"/>
-  </ds:schemaRefs>
-</ds:datastoreItem>
+<file path=customXml/item3.xml><?xml version="1.0" encoding="utf-8"?>
+<p:properties xmlns:p="http://schemas.microsoft.com/office/2006/metadata/properties" xmlns:xsi="http://www.w3.org/2001/XMLSchema-instance" xmlns:pc="http://schemas.microsoft.com/office/infopath/2007/PartnerControls">
+  <documentManagement>
+    <_activity xmlns="539bf27b-6ba9-4563-9663-8e6293fc5b3b" xsi:nil="true"/>
+  </documentManagement>
+</p:properties>
 </file>
 
-<file path=customXml/itemProps3.xml><?xml version="1.0" encoding="utf-8"?>
+<file path=customXml/itemProps1.xml><?xml version="1.0" encoding="utf-8"?>
 <ds:datastoreItem xmlns:ds="http://schemas.openxmlformats.org/officeDocument/2006/customXml" ds:itemID="{0050FDAE-37C5-46CD-BAE4-FA37479A6ACD}">
   <ds:schemaRefs>
     <ds:schemaRef ds:uri="539bf27b-6ba9-4563-9663-8e6293fc5b3b"/>
@@ -11198,4 +11086,28 @@
     <ds:schemaRef ds:uri="http://www.w3.org/2001/XMLSchema"/>
   </ds:schemaRefs>
 </ds:datastoreItem>
+</file>
+
+<file path=customXml/itemProps2.xml><?xml version="1.0" encoding="utf-8"?>
+<ds:datastoreItem xmlns:ds="http://schemas.openxmlformats.org/officeDocument/2006/customXml" ds:itemID="{349F7CF4-910C-43BC-9DCB-33F198C0109A}">
+  <ds:schemaRefs>
+    <ds:schemaRef ds:uri="http://schemas.microsoft.com/sharepoint/v3/contenttype/forms"/>
+  </ds:schemaRefs>
+</ds:datastoreItem>
+</file>
+
+<file path=customXml/itemProps3.xml><?xml version="1.0" encoding="utf-8"?>
+<ds:datastoreItem xmlns:ds="http://schemas.openxmlformats.org/officeDocument/2006/customXml" ds:itemID="{83B8D32C-C616-450A-A725-A432762E03AB}">
+  <ds:schemaRefs>
+    <ds:schemaRef ds:uri="539bf27b-6ba9-4563-9663-8e6293fc5b3b"/>
+    <ds:schemaRef ds:uri="http://purl.org/dc/dcmitype/"/>
+    <ds:schemaRef ds:uri="http://purl.org/dc/elements/1.1/"/>
+    <ds:schemaRef ds:uri="http://purl.org/dc/terms/"/>
+    <ds:schemaRef ds:uri="http://schemas.microsoft.com/office/2006/documentManagement/types"/>
+    <ds:schemaRef ds:uri="http://schemas.microsoft.com/office/2006/metadata/properties"/>
+    <ds:schemaRef ds:uri="http://schemas.microsoft.com/office/infopath/2007/PartnerControls"/>
+    <ds:schemaRef ds:uri="http://schemas.openxmlformats.org/package/2006/metadata/core-properties"/>
+    <ds:schemaRef ds:uri="http://www.w3.org/XML/1998/namespace"/>
+  </ds:schemaRefs>
+</ds:datastoreItem>
 </file>
</xml_diff>